<commit_message>
Complete Jianong demo integration and polish docs
</commit_message>
<xml_diff>
--- a/presentation/slides.pptx
+++ b/presentation/slides.pptx
@@ -19,6 +19,7 @@
     <p:sldId id="261" r:id="rId10"/>
     <p:sldId id="262" r:id="rId11"/>
     <p:sldId id="263" r:id="rId12"/>
+    <p:sldId id="267" r:id="rId18"/>
   </p:sldIdLst>
   <p:sldSz cx="9144000" cy="5143500" type="screen16x9"/>
   <p:notesSz cx="5143500" cy="9144000"/>
@@ -1952,21 +1953,9 @@
           <a:bodyPr wrap="square" lIns="0" tIns="0" rIns="0" bIns="0" rtlCol="0" anchor="ctr"/>
           <a:lstStyle/>
           <a:p>
-            <a:pPr marL="0" indent="0" algn="r">
-              <a:buNone/>
-            </a:pPr>
-            <a:r>
-              <a:rPr lang="en-US" sz="1100" i="1" dirty="0">
-                <a:solidFill>
-                  <a:srgbClr val="858585"/>
-                </a:solidFill>
-                <a:latin typeface="Georgia" pitchFamily="34" charset="0"/>
-                <a:ea typeface="Georgia" pitchFamily="34" charset="-122"/>
-                <a:cs typeface="Georgia" pitchFamily="34" charset="-120"/>
-              </a:rPr>
-              <a:t>0X</a:t>
-            </a:r>
-            <a:endParaRPr lang="en-US" sz="1100" dirty="0"/>
+            <a:r>
+              <a:t>10</a:t>
+            </a:r>
           </a:p>
         </p:txBody>
       </p:sp>
@@ -1991,21 +1980,9 @@
           <a:bodyPr wrap="square" lIns="0" tIns="0" rIns="0" bIns="0" rtlCol="0" anchor="ctr"/>
           <a:lstStyle/>
           <a:p>
-            <a:pPr marL="0" indent="0">
-              <a:buNone/>
-            </a:pPr>
-            <a:r>
-              <a:rPr lang="en-US" sz="950" b="1" kern="0" spc="500" dirty="0">
-                <a:solidFill>
-                  <a:srgbClr val="4E2A84"/>
-                </a:solidFill>
-                <a:latin typeface="Calibri" pitchFamily="34" charset="0"/>
-                <a:ea typeface="Calibri" pitchFamily="34" charset="-122"/>
-                <a:cs typeface="Calibri" pitchFamily="34" charset="-120"/>
-              </a:rPr>
-              <a:t>DEMO  /  SCREENSHOT</a:t>
-            </a:r>
-            <a:endParaRPr lang="en-US" sz="950" dirty="0"/>
+            <a:r>
+              <a:t>Interactive tool demo</a:t>
+            </a:r>
           </a:p>
         </p:txBody>
       </p:sp>
@@ -2030,21 +2007,9 @@
           <a:bodyPr wrap="square" lIns="0" tIns="0" rIns="0" bIns="0" rtlCol="0" anchor="ctr"/>
           <a:lstStyle/>
           <a:p>
-            <a:pPr marL="0" indent="0">
-              <a:buNone/>
-            </a:pPr>
-            <a:r>
-              <a:rPr lang="en-US" sz="2600" b="1" dirty="0">
-                <a:solidFill>
-                  <a:srgbClr val="1A1A1A"/>
-                </a:solidFill>
-                <a:latin typeface="Georgia" pitchFamily="34" charset="0"/>
-                <a:ea typeface="Georgia" pitchFamily="34" charset="-122"/>
-                <a:cs typeface="Georgia" pitchFamily="34" charset="-120"/>
-              </a:rPr>
-              <a:t>Live demo: &lt;what you're showing&gt;</a:t>
-            </a:r>
-            <a:endParaRPr lang="en-US" sz="2600" dirty="0"/>
+            <a:r>
+              <a:t>One end-to-end app now connects summarization, classification, and explainability</a:t>
+            </a:r>
           </a:p>
         </p:txBody>
       </p:sp>
@@ -2101,61 +2066,41 @@
           <a:bodyPr wrap="square" rtlCol="0" anchor="ctr"/>
           <a:lstStyle/>
           <a:p>
-            <a:pPr marL="0" indent="0" algn="ctr">
-              <a:buNone/>
-            </a:pPr>
-            <a:r>
-              <a:rPr lang="en-US" sz="1300" i="1" dirty="0">
-                <a:solidFill>
-                  <a:srgbClr val="858585"/>
-                </a:solidFill>
-                <a:latin typeface="Calibri" pitchFamily="34" charset="0"/>
-                <a:ea typeface="Calibri" pitchFamily="34" charset="-122"/>
-                <a:cs typeface="Calibri" pitchFamily="34" charset="-120"/>
-              </a:rPr>
-              <a:t>[ screenshot or live demo placeholder ]</a:t>
-            </a:r>
-            <a:endParaRPr lang="en-US" sz="1300" dirty="0"/>
-          </a:p>
-          <a:p>
-            <a:pPr marL="0" indent="0" algn="ctr">
-              <a:buNone/>
-            </a:pPr>
-            <a:endParaRPr lang="en-US" sz="1300" dirty="0"/>
-          </a:p>
-          <a:p>
-            <a:pPr marL="0" indent="0" algn="ctr">
-              <a:buNone/>
-            </a:pPr>
-            <a:r>
-              <a:rPr lang="en-US" sz="1300" i="1" dirty="0">
-                <a:solidFill>
-                  <a:srgbClr val="858585"/>
-                </a:solidFill>
-                <a:latin typeface="Calibri" pitchFamily="34" charset="0"/>
-                <a:ea typeface="Calibri" pitchFamily="34" charset="-122"/>
-                <a:cs typeface="Calibri" pitchFamily="34" charset="-120"/>
-              </a:rPr>
-              <a:t>app/gradio screenshot, attention heatmap,</a:t>
-            </a:r>
-            <a:endParaRPr lang="en-US" sz="1300" dirty="0"/>
-          </a:p>
-          <a:p>
-            <a:pPr marL="0" indent="0" algn="ctr">
-              <a:buNone/>
-            </a:pPr>
-            <a:r>
-              <a:rPr lang="en-US" sz="1300" i="1" dirty="0">
-                <a:solidFill>
-                  <a:srgbClr val="858585"/>
-                </a:solidFill>
-                <a:latin typeface="Calibri" pitchFamily="34" charset="0"/>
-                <a:ea typeface="Calibri" pitchFamily="34" charset="-122"/>
-                <a:cs typeface="Calibri" pitchFamily="34" charset="-120"/>
-              </a:rPr>
-              <a:t>or whatever fills most of the slide</a:t>
-            </a:r>
-            <a:endParaRPr lang="en-US" sz="1300" dirty="0"/>
+            <a:r>
+              <a:t>Input case text</a:t>
+            </a:r>
+          </a:p>
+          <a:p/>
+          <a:p>
+            <a:r>
+              <a:t>1. LexRank trims long case records into a manageable evidence packet</a:t>
+            </a:r>
+          </a:p>
+          <a:p>
+            <a:r>
+              <a:t>2. BART generates long and short summaries from the reduced text</a:t>
+            </a:r>
+          </a:p>
+          <a:p>
+            <a:r>
+              <a:t>3. T5 compresses the short summary into a tiny one-line version</a:t>
+            </a:r>
+          </a:p>
+          <a:p>
+            <a:r>
+              <a:t>4. Legal-BERT predicts class action + grouped case type</a:t>
+            </a:r>
+          </a:p>
+          <a:p>
+            <a:r>
+              <a:t>5. The Explainability tab shows LR SHAP plots and a BERT attention heatmap</a:t>
+            </a:r>
+          </a:p>
+          <a:p/>
+          <a:p>
+            <a:r>
+              <a:t>Tabs: Summaries | Predictions | Explainability</a:t>
+            </a:r>
           </a:p>
         </p:txBody>
       </p:sp>
@@ -2180,32 +2125,9 @@
           <a:bodyPr wrap="square" lIns="0" tIns="0" rIns="0" bIns="0" rtlCol="0" anchor="ctr"/>
           <a:lstStyle/>
           <a:p>
-            <a:pPr marL="0" indent="0">
-              <a:buNone/>
-            </a:pPr>
-            <a:r>
-              <a:rPr lang="en-US" sz="1100" dirty="0">
-                <a:solidFill>
-                  <a:srgbClr val="858585"/>
-                </a:solidFill>
-                <a:latin typeface="Calibri" pitchFamily="34" charset="0"/>
-                <a:ea typeface="Calibri" pitchFamily="34" charset="-122"/>
-                <a:cs typeface="Calibri" pitchFamily="34" charset="-120"/>
-              </a:rPr>
-              <a:t>Demo URL: </a:t>
-            </a:r>
-            <a:r>
-              <a:rPr lang="en-US" sz="1100" dirty="0">
-                <a:solidFill>
-                  <a:srgbClr val="4E2A84"/>
-                </a:solidFill>
-                <a:latin typeface="Calibri" pitchFamily="34" charset="0"/>
-                <a:ea typeface="Calibri" pitchFamily="34" charset="-122"/>
-                <a:cs typeface="Calibri" pitchFamily="34" charset="-120"/>
-              </a:rPr>
-              <a:t>https://huggingface.co/spaces/&lt;team&gt;/multilexsum-demo</a:t>
-            </a:r>
-            <a:endParaRPr lang="en-US" sz="1100" dirty="0"/>
+            <a:r>
+              <a:t>Local demo: python -m app.gradio_app   |   Spaces entrypoint: app.py</a:t>
+            </a:r>
           </a:p>
         </p:txBody>
       </p:sp>
@@ -2255,34 +2177,115 @@
           <a:bodyPr wrap="square" lIns="0" tIns="0" rIns="0" bIns="0" rtlCol="0" anchor="ctr"/>
           <a:lstStyle/>
           <a:p>
-            <a:pPr marL="0" indent="0" algn="r">
+            <a:r>
+              <a:t>11</a:t>
+            </a:r>
+          </a:p>
+        </p:txBody>
+      </p:sp>
+      <p:sp>
+        <p:nvSpPr>
+          <p:cNvPr id="3" name="Text 1"/>
+          <p:cNvSpPr/>
+          <p:nvPr/>
+        </p:nvSpPr>
+        <p:spPr>
+          <a:xfrm>
+            <a:off x="640080" y="411480"/>
+            <a:ext cx="6400800" cy="274320"/>
+          </a:xfrm>
+          <a:prstGeom prst="rect">
+            <a:avLst/>
+          </a:prstGeom>
+          <a:noFill/>
+          <a:ln/>
+        </p:spPr>
+        <p:txBody>
+          <a:bodyPr wrap="square" lIns="0" tIns="0" rIns="0" bIns="0" rtlCol="0" anchor="ctr"/>
+          <a:lstStyle/>
+          <a:p>
+            <a:r>
+              <a:t>Explainability &amp; error analysis</a:t>
+            </a:r>
+          </a:p>
+        </p:txBody>
+      </p:sp>
+      <p:sp>
+        <p:nvSpPr>
+          <p:cNvPr id="4" name="Text 2"/>
+          <p:cNvSpPr/>
+          <p:nvPr/>
+        </p:nvSpPr>
+        <p:spPr>
+          <a:xfrm>
+            <a:off x="640080" y="777240"/>
+            <a:ext cx="8229600" cy="502920"/>
+          </a:xfrm>
+          <a:prstGeom prst="rect">
+            <a:avLst/>
+          </a:prstGeom>
+          <a:noFill/>
+          <a:ln/>
+        </p:spPr>
+        <p:txBody>
+          <a:bodyPr wrap="square" lIns="0" tIns="0" rIns="0" bIns="0" rtlCol="0" anchor="ctr"/>
+          <a:lstStyle/>
+          <a:p>
+            <a:r>
+              <a:t>The app now has real evidence-backed cases, not placeholders</a:t>
+            </a:r>
+          </a:p>
+        </p:txBody>
+      </p:sp>
+      <p:sp>
+        <p:nvSpPr>
+          <p:cNvPr id="5" name="Text 3"/>
+          <p:cNvSpPr/>
+          <p:nvPr/>
+        </p:nvSpPr>
+        <p:spPr>
+          <a:xfrm>
+            <a:off x="640080" y="1417320"/>
+            <a:ext cx="868680" cy="777240"/>
+          </a:xfrm>
+          <a:prstGeom prst="rect">
+            <a:avLst/>
+          </a:prstGeom>
+          <a:noFill/>
+          <a:ln/>
+        </p:spPr>
+        <p:txBody>
+          <a:bodyPr wrap="square" lIns="0" tIns="0" rIns="0" bIns="0" rtlCol="0" anchor="ctr"/>
+          <a:lstStyle/>
+          <a:p>
+            <a:pPr marL="0" indent="0" algn="l">
               <a:buNone/>
             </a:pPr>
             <a:r>
-              <a:rPr lang="en-US" sz="1100" i="1" dirty="0">
-                <a:solidFill>
-                  <a:srgbClr val="858585"/>
+              <a:rPr lang="en-US" sz="4400" b="1" dirty="0">
+                <a:solidFill>
+                  <a:srgbClr val="4E2A84"/>
                 </a:solidFill>
                 <a:latin typeface="Georgia" pitchFamily="34" charset="0"/>
                 <a:ea typeface="Georgia" pitchFamily="34" charset="-122"/>
                 <a:cs typeface="Georgia" pitchFamily="34" charset="-120"/>
               </a:rPr>
-              <a:t>12</a:t>
-            </a:r>
-            <a:endParaRPr lang="en-US" sz="1100" dirty="0"/>
-          </a:p>
-        </p:txBody>
-      </p:sp>
-      <p:sp>
-        <p:nvSpPr>
-          <p:cNvPr id="3" name="Text 1"/>
-          <p:cNvSpPr/>
-          <p:nvPr/>
-        </p:nvSpPr>
-        <p:spPr>
-          <a:xfrm>
-            <a:off x="640080" y="411480"/>
-            <a:ext cx="6400800" cy="274320"/>
+              <a:t>01</a:t>
+            </a:r>
+            <a:endParaRPr lang="en-US" sz="4400" dirty="0"/>
+          </a:p>
+        </p:txBody>
+      </p:sp>
+      <p:sp>
+        <p:nvSpPr>
+          <p:cNvPr id="6" name="Text 4"/>
+          <p:cNvSpPr/>
+          <p:nvPr/>
+        </p:nvSpPr>
+        <p:spPr>
+          <a:xfrm>
+            <a:off x="1645920" y="1490472"/>
+            <a:ext cx="6858000" cy="292608"/>
           </a:xfrm>
           <a:prstGeom prst="rect">
             <a:avLst/>
@@ -2294,72 +2297,141 @@
           <a:bodyPr wrap="square" lIns="0" tIns="0" rIns="0" bIns="0" rtlCol="0" anchor="ctr"/>
           <a:lstStyle/>
           <a:p>
-            <a:pPr marL="0" indent="0">
+            <a:r>
+              <a:t>What the app explains</a:t>
+            </a:r>
+          </a:p>
+        </p:txBody>
+      </p:sp>
+      <p:sp>
+        <p:nvSpPr>
+          <p:cNvPr id="7" name="Text 5"/>
+          <p:cNvSpPr/>
+          <p:nvPr/>
+        </p:nvSpPr>
+        <p:spPr>
+          <a:xfrm>
+            <a:off x="1645920" y="1783080"/>
+            <a:ext cx="6858000" cy="411480"/>
+          </a:xfrm>
+          <a:prstGeom prst="rect">
+            <a:avLst/>
+          </a:prstGeom>
+          <a:noFill/>
+          <a:ln/>
+        </p:spPr>
+        <p:txBody>
+          <a:bodyPr wrap="square" lIns="0" tIns="0" rIns="0" bIns="0" rtlCol="0" anchor="ctr"/>
+          <a:lstStyle/>
+          <a:p>
+            <a:r>
+              <a:t>LR SHAP token plots render live for both tasks on the generated long summary. The BERT attention panel is included for qualitative inspection only; it is not treated as causal proof.</a:t>
+            </a:r>
+          </a:p>
+        </p:txBody>
+      </p:sp>
+      <p:sp>
+        <p:nvSpPr>
+          <p:cNvPr id="8" name="Text 6"/>
+          <p:cNvSpPr/>
+          <p:nvPr/>
+        </p:nvSpPr>
+        <p:spPr>
+          <a:xfrm>
+            <a:off x="640080" y="2286000"/>
+            <a:ext cx="868680" cy="777240"/>
+          </a:xfrm>
+          <a:prstGeom prst="rect">
+            <a:avLst/>
+          </a:prstGeom>
+          <a:noFill/>
+          <a:ln/>
+        </p:spPr>
+        <p:txBody>
+          <a:bodyPr wrap="square" lIns="0" tIns="0" rIns="0" bIns="0" rtlCol="0" anchor="ctr"/>
+          <a:lstStyle/>
+          <a:p>
+            <a:pPr marL="0" indent="0" algn="l">
               <a:buNone/>
             </a:pPr>
             <a:r>
-              <a:rPr lang="en-US" sz="950" b="1" kern="0" spc="500" dirty="0">
+              <a:rPr lang="en-US" sz="4400" b="1" dirty="0">
                 <a:solidFill>
                   <a:srgbClr val="4E2A84"/>
-                </a:solidFill>
-                <a:latin typeface="Calibri" pitchFamily="34" charset="0"/>
-                <a:ea typeface="Calibri" pitchFamily="34" charset="-122"/>
-                <a:cs typeface="Calibri" pitchFamily="34" charset="-120"/>
-              </a:rPr>
-              <a:t>CONCLUSION</a:t>
-            </a:r>
-            <a:endParaRPr lang="en-US" sz="950" dirty="0"/>
-          </a:p>
-        </p:txBody>
-      </p:sp>
-      <p:sp>
-        <p:nvSpPr>
-          <p:cNvPr id="4" name="Text 2"/>
-          <p:cNvSpPr/>
-          <p:nvPr/>
-        </p:nvSpPr>
-        <p:spPr>
-          <a:xfrm>
-            <a:off x="640080" y="777240"/>
-            <a:ext cx="8229600" cy="502920"/>
-          </a:xfrm>
-          <a:prstGeom prst="rect">
-            <a:avLst/>
-          </a:prstGeom>
-          <a:noFill/>
-          <a:ln/>
-        </p:spPr>
-        <p:txBody>
-          <a:bodyPr wrap="square" lIns="0" tIns="0" rIns="0" bIns="0" rtlCol="0" anchor="ctr"/>
-          <a:lstStyle/>
-          <a:p>
-            <a:pPr marL="0" indent="0">
-              <a:buNone/>
-            </a:pPr>
-            <a:r>
-              <a:rPr lang="en-US" sz="2600" b="1" dirty="0">
-                <a:solidFill>
-                  <a:srgbClr val="1A1A1A"/>
                 </a:solidFill>
                 <a:latin typeface="Georgia" pitchFamily="34" charset="0"/>
                 <a:ea typeface="Georgia" pitchFamily="34" charset="-122"/>
                 <a:cs typeface="Georgia" pitchFamily="34" charset="-120"/>
               </a:rPr>
-              <a:t>Lessons &amp; future work</a:t>
-            </a:r>
-            <a:endParaRPr lang="en-US" sz="2600" dirty="0"/>
-          </a:p>
-        </p:txBody>
-      </p:sp>
-      <p:sp>
-        <p:nvSpPr>
-          <p:cNvPr id="5" name="Text 3"/>
-          <p:cNvSpPr/>
-          <p:nvPr/>
-        </p:nvSpPr>
-        <p:spPr>
-          <a:xfrm>
-            <a:off x="640080" y="1417320"/>
+              <a:t>02</a:t>
+            </a:r>
+            <a:endParaRPr lang="en-US" sz="4400" dirty="0"/>
+          </a:p>
+        </p:txBody>
+      </p:sp>
+      <p:sp>
+        <p:nvSpPr>
+          <p:cNvPr id="9" name="Text 7"/>
+          <p:cNvSpPr/>
+          <p:nvPr/>
+        </p:nvSpPr>
+        <p:spPr>
+          <a:xfrm>
+            <a:off x="1645920" y="2359152"/>
+            <a:ext cx="6858000" cy="292608"/>
+          </a:xfrm>
+          <a:prstGeom prst="rect">
+            <a:avLst/>
+          </a:prstGeom>
+          <a:noFill/>
+          <a:ln/>
+        </p:spPr>
+        <p:txBody>
+          <a:bodyPr wrap="square" lIns="0" tIns="0" rIns="0" bIns="0" rtlCol="0" anchor="ctr"/>
+          <a:lstStyle/>
+          <a:p>
+            <a:r>
+              <a:t>Five concrete cases</a:t>
+            </a:r>
+          </a:p>
+        </p:txBody>
+      </p:sp>
+      <p:sp>
+        <p:nvSpPr>
+          <p:cNvPr id="10" name="Text 8"/>
+          <p:cNvSpPr/>
+          <p:nvPr/>
+        </p:nvSpPr>
+        <p:spPr>
+          <a:xfrm>
+            <a:off x="1645920" y="2651760"/>
+            <a:ext cx="6858000" cy="411480"/>
+          </a:xfrm>
+          <a:prstGeom prst="rect">
+            <a:avLst/>
+          </a:prstGeom>
+          <a:noFill/>
+          <a:ln/>
+        </p:spPr>
+        <p:txBody>
+          <a:bodyPr wrap="square" lIns="0" tIns="0" rIns="0" bIns="0" rtlCol="0" anchor="ctr"/>
+          <a:lstStyle/>
+          <a:p>
+            <a:r>
+              <a:t>Notebook 06 and results/error_cases.md now freeze five categories: model disagreement, summary divergence, high-confidence wrong, low-confidence correct, and rare-class recovery.</a:t>
+            </a:r>
+          </a:p>
+        </p:txBody>
+      </p:sp>
+      <p:sp>
+        <p:nvSpPr>
+          <p:cNvPr id="11" name="Text 9"/>
+          <p:cNvSpPr/>
+          <p:nvPr/>
+        </p:nvSpPr>
+        <p:spPr>
+          <a:xfrm>
+            <a:off x="640080" y="3154680"/>
             <a:ext cx="868680" cy="777240"/>
           </a:xfrm>
           <a:prstGeom prst="rect">
@@ -2384,7 +2456,7 @@
                 <a:ea typeface="Georgia" pitchFamily="34" charset="-122"/>
                 <a:cs typeface="Georgia" pitchFamily="34" charset="-120"/>
               </a:rPr>
-              <a:t>01</a:t>
+              <a:t>03</a:t>
             </a:r>
             <a:endParaRPr lang="en-US" sz="4400" dirty="0"/>
           </a:p>
@@ -2392,13 +2464,13 @@
       </p:sp>
       <p:sp>
         <p:nvSpPr>
-          <p:cNvPr id="6" name="Text 4"/>
-          <p:cNvSpPr/>
-          <p:nvPr/>
-        </p:nvSpPr>
-        <p:spPr>
-          <a:xfrm>
-            <a:off x="1645920" y="1490472"/>
+          <p:cNvPr id="12" name="Text 10"/>
+          <p:cNvSpPr/>
+          <p:nvPr/>
+        </p:nvSpPr>
+        <p:spPr>
+          <a:xfrm>
+            <a:off x="1645920" y="3227832"/>
             <a:ext cx="6858000" cy="292608"/>
           </a:xfrm>
           <a:prstGeom prst="rect">
@@ -2411,21 +2483,228 @@
           <a:bodyPr wrap="square" lIns="0" tIns="0" rIns="0" bIns="0" rtlCol="0" anchor="ctr"/>
           <a:lstStyle/>
           <a:p>
-            <a:pPr marL="0" indent="0">
+            <a:r>
+              <a:t>What the errors show</a:t>
+            </a:r>
+          </a:p>
+        </p:txBody>
+      </p:sp>
+      <p:sp>
+        <p:nvSpPr>
+          <p:cNvPr id="13" name="Text 11"/>
+          <p:cNvSpPr/>
+          <p:nvPr/>
+        </p:nvSpPr>
+        <p:spPr>
+          <a:xfrm>
+            <a:off x="1645920" y="3520440"/>
+            <a:ext cx="6858000" cy="411480"/>
+          </a:xfrm>
+          <a:prstGeom prst="rect">
+            <a:avLst/>
+          </a:prstGeom>
+          <a:noFill/>
+          <a:ln/>
+        </p:spPr>
+        <p:txBody>
+          <a:bodyPr wrap="square" lIns="0" tIns="0" rIns="0" bIns="0" rtlCol="0" anchor="ctr"/>
+          <a:lstStyle/>
+          <a:p>
+            <a:r>
+              <a:t>Boundary cases like IM-CA-0025 split the model families, prison-heavy wording pulls multiple models toward Criminal Justice, and Legal-BERT is the only model that reliably recovers the rare Healthcare &amp; Disability class.</a:t>
+            </a:r>
+          </a:p>
+        </p:txBody>
+      </p:sp>
+      <p:sp>
+        <p:nvSpPr>
+          <p:cNvPr id="14" name="Text 12"/>
+          <p:cNvSpPr/>
+          <p:nvPr/>
+        </p:nvSpPr>
+        <p:spPr>
+          <a:xfrm>
+            <a:off x="640080" y="4251960"/>
+            <a:ext cx="8229600" cy="502920"/>
+          </a:xfrm>
+          <a:prstGeom prst="rect">
+            <a:avLst/>
+          </a:prstGeom>
+          <a:noFill/>
+          <a:ln/>
+        </p:spPr>
+        <p:txBody>
+          <a:bodyPr wrap="square" lIns="0" tIns="0" rIns="0" bIns="0" rtlCol="0" anchor="ctr"/>
+          <a:lstStyle/>
+          <a:p>
+            <a:r>
+              <a:t>Artifacts: results/predictions/*.csv + results/app/explanations/*.png</a:t>
+            </a:r>
+          </a:p>
+        </p:txBody>
+      </p:sp>
+    </p:spTree>
+  </p:cSld>
+  <p:clrMapOvr>
+    <a:masterClrMapping/>
+  </p:clrMapOvr>
+</p:sld>
+</file>
+
+<file path=ppt/slides/slide12.xml><?xml version="1.0" encoding="utf-8"?>
+<p:sld xmlns:a="http://schemas.openxmlformats.org/drawingml/2006/main" xmlns:p="http://schemas.openxmlformats.org/presentationml/2006/main" xmlns:r="http://schemas.openxmlformats.org/officeDocument/2006/relationships">
+  <p:cSld>
+    <p:spTree>
+      <p:nvGrpSpPr>
+        <p:cNvPr id="1" name=""/>
+        <p:cNvGrpSpPr/>
+        <p:nvPr/>
+      </p:nvGrpSpPr>
+      <p:grpSpPr/>
+      <p:sp>
+        <p:nvSpPr>
+          <p:cNvPr id="2" name="Text 0"/>
+          <p:cNvSpPr/>
+          <p:nvPr/>
+        </p:nvSpPr>
+        <p:spPr>
+          <a:xfrm>
+            <a:off x="8229600" y="411480"/>
+            <a:ext cx="548640" cy="320040"/>
+          </a:xfrm>
+          <a:prstGeom prst="rect">
+            <a:avLst/>
+          </a:prstGeom>
+          <a:noFill/>
+          <a:ln/>
+        </p:spPr>
+        <p:txBody>
+          <a:bodyPr wrap="square" lIns="0" tIns="0" rIns="0" bIns="0" rtlCol="0" anchor="ctr"/>
+          <a:lstStyle/>
+          <a:p>
+            <a:r>
+              <a:t>12</a:t>
+            </a:r>
+          </a:p>
+        </p:txBody>
+      </p:sp>
+      <p:sp>
+        <p:nvSpPr>
+          <p:cNvPr id="3" name="Text 1"/>
+          <p:cNvSpPr/>
+          <p:nvPr/>
+        </p:nvSpPr>
+        <p:spPr>
+          <a:xfrm>
+            <a:off x="640080" y="411480"/>
+            <a:ext cx="6400800" cy="274320"/>
+          </a:xfrm>
+          <a:prstGeom prst="rect">
+            <a:avLst/>
+          </a:prstGeom>
+          <a:noFill/>
+          <a:ln/>
+        </p:spPr>
+        <p:txBody>
+          <a:bodyPr wrap="square" lIns="0" tIns="0" rIns="0" bIns="0" rtlCol="0" anchor="ctr"/>
+          <a:lstStyle/>
+          <a:p>
+            <a:r>
+              <a:t>Lessons &amp; future work</a:t>
+            </a:r>
+          </a:p>
+        </p:txBody>
+      </p:sp>
+      <p:sp>
+        <p:nvSpPr>
+          <p:cNvPr id="4" name="Text 2"/>
+          <p:cNvSpPr/>
+          <p:nvPr/>
+        </p:nvSpPr>
+        <p:spPr>
+          <a:xfrm>
+            <a:off x="640080" y="777240"/>
+            <a:ext cx="8229600" cy="502920"/>
+          </a:xfrm>
+          <a:prstGeom prst="rect">
+            <a:avLst/>
+          </a:prstGeom>
+          <a:noFill/>
+          <a:ln/>
+        </p:spPr>
+        <p:txBody>
+          <a:bodyPr wrap="square" lIns="0" tIns="0" rIns="0" bIns="0" rtlCol="0" anchor="ctr"/>
+          <a:lstStyle/>
+          <a:p>
+            <a:r>
+              <a:t>What the project taught us and what remains open</a:t>
+            </a:r>
+          </a:p>
+        </p:txBody>
+      </p:sp>
+      <p:sp>
+        <p:nvSpPr>
+          <p:cNvPr id="5" name="Text 3"/>
+          <p:cNvSpPr/>
+          <p:nvPr/>
+        </p:nvSpPr>
+        <p:spPr>
+          <a:xfrm>
+            <a:off x="640080" y="1417320"/>
+            <a:ext cx="868680" cy="777240"/>
+          </a:xfrm>
+          <a:prstGeom prst="rect">
+            <a:avLst/>
+          </a:prstGeom>
+          <a:noFill/>
+          <a:ln/>
+        </p:spPr>
+        <p:txBody>
+          <a:bodyPr wrap="square" lIns="0" tIns="0" rIns="0" bIns="0" rtlCol="0" anchor="ctr"/>
+          <a:lstStyle/>
+          <a:p>
+            <a:pPr marL="0" indent="0" algn="l">
               <a:buNone/>
             </a:pPr>
             <a:r>
-              <a:rPr lang="en-US" sz="1500" b="1" dirty="0">
-                <a:solidFill>
-                  <a:srgbClr val="1A1A1A"/>
+              <a:rPr lang="en-US" sz="4400" b="1" dirty="0">
+                <a:solidFill>
+                  <a:srgbClr val="4E2A84"/>
                 </a:solidFill>
                 <a:latin typeface="Georgia" pitchFamily="34" charset="0"/>
                 <a:ea typeface="Georgia" pitchFamily="34" charset="-122"/>
                 <a:cs typeface="Georgia" pitchFamily="34" charset="-120"/>
               </a:rPr>
+              <a:t>01</a:t>
+            </a:r>
+            <a:endParaRPr lang="en-US" sz="4400" dirty="0"/>
+          </a:p>
+        </p:txBody>
+      </p:sp>
+      <p:sp>
+        <p:nvSpPr>
+          <p:cNvPr id="6" name="Text 4"/>
+          <p:cNvSpPr/>
+          <p:nvPr/>
+        </p:nvSpPr>
+        <p:spPr>
+          <a:xfrm>
+            <a:off x="1645920" y="1490472"/>
+            <a:ext cx="6858000" cy="292608"/>
+          </a:xfrm>
+          <a:prstGeom prst="rect">
+            <a:avLst/>
+          </a:prstGeom>
+          <a:noFill/>
+          <a:ln/>
+        </p:spPr>
+        <p:txBody>
+          <a:bodyPr wrap="square" lIns="0" tIns="0" rIns="0" bIns="0" rtlCol="0" anchor="ctr"/>
+          <a:lstStyle/>
+          <a:p>
+            <a:r>
               <a:t>Summarization takeaway</a:t>
             </a:r>
-            <a:endParaRPr lang="en-US" sz="1500" dirty="0"/>
           </a:p>
         </p:txBody>
       </p:sp>
@@ -2450,21 +2729,9 @@
           <a:bodyPr wrap="square" lIns="0" tIns="0" rIns="0" bIns="0" rtlCol="0" anchor="ctr"/>
           <a:lstStyle/>
           <a:p>
-            <a:pPr marL="0" indent="0">
-              <a:buNone/>
-            </a:pPr>
-            <a:r>
-              <a:rPr lang="en-US" sz="1100" dirty="0">
-                <a:solidFill>
-                  <a:srgbClr val="4A4A4A"/>
-                </a:solidFill>
-                <a:latin typeface="Calibri" pitchFamily="34" charset="0"/>
-                <a:ea typeface="Calibri" pitchFamily="34" charset="-122"/>
-                <a:cs typeface="Calibri" pitchFamily="34" charset="-120"/>
-              </a:rPr>
-              <a:t>One technical lesson from §2 — what worked or what surprised you.</a:t>
-            </a:r>
-            <a:endParaRPr lang="en-US" sz="1100" dirty="0"/>
+            <a:r>
+              <a:t>Long legal cases need aggressive extractive compression before standard encoder-decoder models can summarize them reliably. The hierarchical pipeline is what makes the project feasible on commodity hardware.</a:t>
+            </a:r>
           </a:p>
         </p:txBody>
       </p:sp>
@@ -2528,96 +2795,72 @@
           <a:bodyPr wrap="square" lIns="0" tIns="0" rIns="0" bIns="0" rtlCol="0" anchor="ctr"/>
           <a:lstStyle/>
           <a:p>
-            <a:pPr marL="0" indent="0">
+            <a:r>
+              <a:t>Classification takeaway</a:t>
+            </a:r>
+          </a:p>
+        </p:txBody>
+      </p:sp>
+      <p:sp>
+        <p:nvSpPr>
+          <p:cNvPr id="10" name="Text 8"/>
+          <p:cNvSpPr/>
+          <p:nvPr/>
+        </p:nvSpPr>
+        <p:spPr>
+          <a:xfrm>
+            <a:off x="1645920" y="2651760"/>
+            <a:ext cx="6858000" cy="411480"/>
+          </a:xfrm>
+          <a:prstGeom prst="rect">
+            <a:avLst/>
+          </a:prstGeom>
+          <a:noFill/>
+          <a:ln/>
+        </p:spPr>
+        <p:txBody>
+          <a:bodyPr wrap="square" lIns="0" tIns="0" rIns="0" bIns="0" rtlCol="0" anchor="ctr"/>
+          <a:lstStyle/>
+          <a:p>
+            <a:r>
+              <a:t>Legal-BERT is the strongest classifier, especially on rarer case-type groups. The biggest gains over LR and Bi-LSTM show up on Healthcare &amp; Disability, where classical models collapse.</a:t>
+            </a:r>
+          </a:p>
+        </p:txBody>
+      </p:sp>
+      <p:sp>
+        <p:nvSpPr>
+          <p:cNvPr id="11" name="Text 9"/>
+          <p:cNvSpPr/>
+          <p:nvPr/>
+        </p:nvSpPr>
+        <p:spPr>
+          <a:xfrm>
+            <a:off x="640080" y="3154680"/>
+            <a:ext cx="868680" cy="777240"/>
+          </a:xfrm>
+          <a:prstGeom prst="rect">
+            <a:avLst/>
+          </a:prstGeom>
+          <a:noFill/>
+          <a:ln/>
+        </p:spPr>
+        <p:txBody>
+          <a:bodyPr wrap="square" lIns="0" tIns="0" rIns="0" bIns="0" rtlCol="0" anchor="ctr"/>
+          <a:lstStyle/>
+          <a:p>
+            <a:pPr marL="0" indent="0" algn="l">
               <a:buNone/>
             </a:pPr>
             <a:r>
-              <a:rPr lang="en-US" sz="1500" b="1" dirty="0">
-                <a:solidFill>
-                  <a:srgbClr val="1A1A1A"/>
+              <a:rPr lang="en-US" sz="4400" b="1" dirty="0">
+                <a:solidFill>
+                  <a:srgbClr val="4E2A84"/>
                 </a:solidFill>
                 <a:latin typeface="Georgia" pitchFamily="34" charset="0"/>
                 <a:ea typeface="Georgia" pitchFamily="34" charset="-122"/>
                 <a:cs typeface="Georgia" pitchFamily="34" charset="-120"/>
               </a:rPr>
-              <a:t>Classification takeaway</a:t>
-            </a:r>
-            <a:endParaRPr lang="en-US" sz="1500" dirty="0"/>
-          </a:p>
-        </p:txBody>
-      </p:sp>
-      <p:sp>
-        <p:nvSpPr>
-          <p:cNvPr id="10" name="Text 8"/>
-          <p:cNvSpPr/>
-          <p:nvPr/>
-        </p:nvSpPr>
-        <p:spPr>
-          <a:xfrm>
-            <a:off x="1645920" y="2651760"/>
-            <a:ext cx="6858000" cy="411480"/>
-          </a:xfrm>
-          <a:prstGeom prst="rect">
-            <a:avLst/>
-          </a:prstGeom>
-          <a:noFill/>
-          <a:ln/>
-        </p:spPr>
-        <p:txBody>
-          <a:bodyPr wrap="square" lIns="0" tIns="0" rIns="0" bIns="0" rtlCol="0" anchor="ctr"/>
-          <a:lstStyle/>
-          <a:p>
-            <a:pPr marL="0" indent="0">
-              <a:buNone/>
-            </a:pPr>
-            <a:r>
-              <a:rPr lang="en-US" sz="1100" dirty="0">
-                <a:solidFill>
-                  <a:srgbClr val="4A4A4A"/>
-                </a:solidFill>
-                <a:latin typeface="Calibri" pitchFamily="34" charset="0"/>
-                <a:ea typeface="Calibri" pitchFamily="34" charset="-122"/>
-                <a:cs typeface="Calibri" pitchFamily="34" charset="-120"/>
-              </a:rPr>
-              <a:t>One technical lesson from §3 — model choice, feature engineering, or failure mode.</a:t>
-            </a:r>
-            <a:endParaRPr lang="en-US" sz="1100" dirty="0"/>
-          </a:p>
-        </p:txBody>
-      </p:sp>
-      <p:sp>
-        <p:nvSpPr>
-          <p:cNvPr id="11" name="Text 9"/>
-          <p:cNvSpPr/>
-          <p:nvPr/>
-        </p:nvSpPr>
-        <p:spPr>
-          <a:xfrm>
-            <a:off x="640080" y="3154680"/>
-            <a:ext cx="868680" cy="777240"/>
-          </a:xfrm>
-          <a:prstGeom prst="rect">
-            <a:avLst/>
-          </a:prstGeom>
-          <a:noFill/>
-          <a:ln/>
-        </p:spPr>
-        <p:txBody>
-          <a:bodyPr wrap="square" lIns="0" tIns="0" rIns="0" bIns="0" rtlCol="0" anchor="ctr"/>
-          <a:lstStyle/>
-          <a:p>
-            <a:pPr marL="0" indent="0" algn="l">
-              <a:buNone/>
-            </a:pPr>
-            <a:r>
-              <a:rPr lang="en-US" sz="4400" b="1" dirty="0">
-                <a:solidFill>
-                  <a:srgbClr val="4E2A84"/>
-                </a:solidFill>
-                <a:latin typeface="Georgia" pitchFamily="34" charset="0"/>
-                <a:ea typeface="Georgia" pitchFamily="34" charset="-122"/>
-                <a:cs typeface="Georgia" pitchFamily="34" charset="-120"/>
-              </a:rPr>
               <a:t>03</a:t>
             </a:r>
             <a:endParaRPr lang="en-US" sz="4400" dirty="0"/>
@@ -2645,21 +2888,9 @@
           <a:bodyPr wrap="square" lIns="0" tIns="0" rIns="0" bIns="0" rtlCol="0" anchor="ctr"/>
           <a:lstStyle/>
           <a:p>
-            <a:pPr marL="0" indent="0">
-              <a:buNone/>
-            </a:pPr>
-            <a:r>
-              <a:rPr lang="en-US" sz="1500" b="1" dirty="0">
-                <a:solidFill>
-                  <a:srgbClr val="1A1A1A"/>
-                </a:solidFill>
-                <a:latin typeface="Georgia" pitchFamily="34" charset="0"/>
-                <a:ea typeface="Georgia" pitchFamily="34" charset="-122"/>
-                <a:cs typeface="Georgia" pitchFamily="34" charset="-120"/>
-              </a:rPr>
+            <a:r>
               <a:t>Tool / integration takeaway</a:t>
             </a:r>
-            <a:endParaRPr lang="en-US" sz="1500" dirty="0"/>
           </a:p>
         </p:txBody>
       </p:sp>
@@ -2684,21 +2915,9 @@
           <a:bodyPr wrap="square" lIns="0" tIns="0" rIns="0" bIns="0" rtlCol="0" anchor="ctr"/>
           <a:lstStyle/>
           <a:p>
-            <a:pPr marL="0" indent="0">
-              <a:buNone/>
-            </a:pPr>
-            <a:r>
-              <a:rPr lang="en-US" sz="1100" dirty="0">
-                <a:solidFill>
-                  <a:srgbClr val="4A4A4A"/>
-                </a:solidFill>
-                <a:latin typeface="Calibri" pitchFamily="34" charset="0"/>
-                <a:ea typeface="Calibri" pitchFamily="34" charset="-122"/>
-                <a:cs typeface="Calibri" pitchFamily="34" charset="-120"/>
-              </a:rPr>
-              <a:t>One lesson from building the Gradio app or error analysis.</a:t>
-            </a:r>
-            <a:endParaRPr lang="en-US" sz="1100" dirty="0"/>
+            <a:r>
+              <a:t>The biggest engineering lesson was ownership-friendly integration: one app contract can reuse the team's summarization and classification artifacts without rewriting upstream code.</a:t>
+            </a:r>
           </a:p>
         </p:txBody>
       </p:sp>
@@ -2723,43 +2942,9 @@
           <a:bodyPr wrap="square" lIns="0" tIns="0" rIns="0" bIns="0" rtlCol="0" anchor="ctr"/>
           <a:lstStyle/>
           <a:p>
-            <a:pPr marL="0" indent="0">
-              <a:buNone/>
-            </a:pPr>
-            <a:r>
-              <a:rPr lang="en-US" sz="1100" b="1" i="1" dirty="0">
-                <a:solidFill>
-                  <a:srgbClr val="9A7E3F"/>
-                </a:solidFill>
-                <a:latin typeface="Georgia" pitchFamily="34" charset="0"/>
-                <a:ea typeface="Georgia" pitchFamily="34" charset="-122"/>
-                <a:cs typeface="Georgia" pitchFamily="34" charset="-120"/>
-              </a:rPr>
-              <a:t>—  </a:t>
-            </a:r>
-            <a:r>
-              <a:rPr lang="en-US" sz="1100" b="1" i="1" dirty="0">
-                <a:solidFill>
-                  <a:srgbClr val="4A4A4A"/>
-                </a:solidFill>
-                <a:latin typeface="Georgia" pitchFamily="34" charset="0"/>
-                <a:ea typeface="Georgia" pitchFamily="34" charset="-122"/>
-                <a:cs typeface="Georgia" pitchFamily="34" charset="-120"/>
-              </a:rPr>
-              <a:t>Future work: </a:t>
-            </a:r>
-            <a:r>
-              <a:rPr lang="en-US" sz="1100" i="1" dirty="0">
-                <a:solidFill>
-                  <a:srgbClr val="4A4A4A"/>
-                </a:solidFill>
-                <a:latin typeface="Georgia" pitchFamily="34" charset="0"/>
-                <a:ea typeface="Georgia" pitchFamily="34" charset="-122"/>
-                <a:cs typeface="Georgia" pitchFamily="34" charset="-120"/>
-              </a:rPr>
-              <a:t>two or three concrete extensions (Legal-LLaMA fine-tune, retrieval-augmented summarization, hierarchical attention pooling).</a:t>
-            </a:r>
-            <a:endParaRPr lang="en-US" sz="1100" dirty="0"/>
+            <a:r>
+              <a:t>Future work: strengthen tiny-summary training, improve long-summary factual consistency, and optionally retrain classifiers on generated summaries later.</a:t>
+            </a:r>
           </a:p>
         </p:txBody>
       </p:sp>

</xml_diff>